<commit_message>
Fit hybrid and BEV as ramp technologies; retitle the S-curve chart
Stage 10 now distinguishes completed diffusion curves (turbo, GDI, CVT;
ceiling estimated) from technologies still on the ramp (hybrid, BEV):
for the latter the ceiling is fixed at 1.0 (takeoff assumed) and only the
rate and midpoint are estimated, with the assumption recorded per
technology. BEV: k = 0.29, midpoint 2032, 10-90% in 15 years. fig18 is
retitled "Three technologies completed the S-curve; hybrid and BEV are
still on the ramp", labels each panel, and the report sentence that
misdescribed the HEV ceiling is corrected. Deck slide 7 text and
narration updated to match.

Co-Authored-By: Claude Fable 5.1 <noreply@anthropic.com>
</commit_message>
<xml_diff>
--- a/MPG Prediction Deck.pptx
+++ b/MPG Prediction Deck.pptx
@@ -3277,8 +3277,8 @@
           <a:p>
             <a:r>
               <a:rPr lang="en-US" dirty="0"/>
-              <a:t>One more piece of context before the model: how does efficiency technology arrive? The answer, over fifty years, is on S-curves. Multi-valve engines, variable valve timing, turbocharging, direct injection, hybrids, and now battery-electrics each diffused through the fleet along a logistic curve, slow, then fast, then saturating. Only the speed differs: direct injection took over about twice as fast as turbocharging. The honest open question is the electric curve. Thirteen years in, the data cannot yet tell an early S-curve from a low plateau, and its fitted ceiling has the widest confidence interval on the page. Treat the dashed part of that line as the least reliable thing in this deck. What every one of these technologies has in common is that it raises fuel economy at a given weight and power. That is exactly the quantity our equation will let us isolate.
-IF ASKED about the fitting: each curve is a three-parameter logistic fit by nonlinear least squares, with the ceiling estimated rather than assumed, and confidence intervals from a residual bootstrap.</a:t>
+              <a:t>One more piece of context before the model: how does efficiency technology actually arrive in the fleet? The answer, over fifty years, is on S-curves. Slow uptake, then a rush, then saturation. The top row shows three technologies that have run the whole course. Turbocharging took fifteen years to go from ten to ninety percent of its eventual share. Direct injection did it in seven. Continuously variable transmissions in ten. Same shape every time; only the clock speed differs, and that is what 'rate constant' means. The bottom row is the two technologies still on the ramp. Hybrids sit at about ten percent of the fleet today. When we fit the same S-curve, the midpoint lands in 2036 and the ten-to-ninety climb takes about twenty-four years, so what you see is the bottom corner of an S whose middle hasn't happened yet. Electrics are on the same footing: thirteen years of data, a fitted midpoint of 2032, a fifteen-year climb. For both, the data pin down how fast they are taking off, not where they stop, so the ceiling is an assumption and the dashed lines are the least reliable thing in this deck. What every one of these technologies has in common is the part that matters for us: each raises fuel economy at a given weight and power. That is the quantity we are about to measure. To measure it we need to know exactly which numbers go into the equation and where each one came from.
+IF ASKED why fit an S to hybrids or electrics at all: the three completed technologies gave no reason to expect a different shape, and the logistic is the standard diffusion model. For the completed curves the ceiling is estimated (turbo 48%, direct injection 54%, CVT 22%); for the two on the ramp the data cannot identify a ceiling, so it is fixed at one and only the rate and midpoint are estimated, with bootstrap confidence intervals. A free fit for electrics flips between an early S-curve and a low plateau depending on the last two data points, which is exactly why we do not report one.</a:t>
             </a:r>
             <a:endParaRPr lang="en-US" dirty="0"/>
           </a:p>
@@ -24327,7 +24327,7 @@
                 <a:ea typeface="Calibri" pitchFamily="34" charset="-122"/>
                 <a:cs typeface="Calibri" pitchFamily="34" charset="-120"/>
               </a:rPr>
-              <a:t>Efficiency technology arrives on S-curves; the EV curve is the youngest</a:t>
+              <a:t>Efficiency technology arrives on S-curves; hybrid and electric are still on the ramp</a:t>
             </a:r>
             <a:endParaRPr lang="en-US" sz="2800" dirty="0"/>
           </a:p>
@@ -24350,7 +24350,7 @@
         <p:spPr>
           <a:xfrm>
             <a:off x="502920" y="1188720"/>
-            <a:ext cx="8307977" cy="4846320"/>
+            <a:ext cx="8186351" cy="4846320"/>
           </a:xfrm>
           <a:prstGeom prst="rect">
             <a:avLst/>
@@ -24382,7 +24382,7 @@
               <a:buNone/>
             </a:pPr>
             <a:r>
-              <a:rPr lang="en-US" sz="1350" dirty="0">
+              <a:rPr lang="en-US" sz="1300" dirty="0">
                 <a:solidFill>
                   <a:srgbClr val="0B0B0B"/>
                 </a:solidFill>
@@ -24390,13 +24390,13 @@
                 <a:ea typeface="Calibri" pitchFamily="34" charset="-122"/>
                 <a:cs typeface="Calibri" pitchFamily="34" charset="-120"/>
               </a:rPr>
-              <a:t>Every efficiency technology diffused on a logistic curve; only the rate differs. </a:t>
+              <a:t>Three technologies have run the whole course and each traced the same S; only the clock speed differs. </a:t>
             </a:r>
             <a:pPr indent="0" marL="0">
               <a:buNone/>
             </a:pPr>
             <a:r>
-              <a:rPr lang="en-US" sz="1350" b="1" dirty="0">
+              <a:rPr lang="en-US" sz="1300" b="1" dirty="0">
                 <a:solidFill>
                   <a:srgbClr val="2A78D6"/>
                 </a:solidFill>
@@ -24411,7 +24411,7 @@
               <a:buNone/>
             </a:pPr>
             <a:r>
-              <a:rPr lang="en-US" sz="1350" dirty="0">
+              <a:rPr lang="en-US" sz="1300" dirty="0">
                 <a:solidFill>
                   <a:srgbClr val="0B0B0B"/>
                 </a:solidFill>
@@ -24419,14 +24419,14 @@
                 <a:ea typeface="Calibri" pitchFamily="34" charset="-122"/>
                 <a:cs typeface="Calibri" pitchFamily="34" charset="-120"/>
               </a:rPr>
-              <a:t>The open question is the BEV curve: the data cannot yet distinguish an early S-curve from a low plateau. Its fitted ceiling carries the widest confidence interval on the page.
+              <a:t>Hybrid and electric are on the ramp: the data pin down how fast they are taking off (10→90% in 24 and 15 years), not where they stop. The ceiling is assumed, the midpoints (2036, 2032) lie beyond the data, and the dashed lines are the least reliable thing in this deck.
 </a:t>
             </a:r>
             <a:pPr indent="0" marL="0">
               <a:buNone/>
             </a:pPr>
             <a:r>
-              <a:rPr lang="en-US" sz="1350" i="1" dirty="0">
+              <a:rPr lang="en-US" sz="1300" i="1" dirty="0">
                 <a:solidFill>
                   <a:srgbClr val="6E6C66"/>
                 </a:solidFill>
@@ -24436,7 +24436,7 @@
               </a:rPr>
               <a:t>Whatever the ceiling, every one of these technologies raises MPG at a given weight and power. That is the productivity we will measure.</a:t>
             </a:r>
-            <a:endParaRPr lang="en-US" sz="1350" dirty="0"/>
+            <a:endParaRPr lang="en-US" sz="1300" dirty="0"/>
           </a:p>
         </p:txBody>
       </p:sp>
@@ -24473,7 +24473,7 @@
                 <a:ea typeface="Calibri" pitchFamily="34" charset="-122"/>
                 <a:cs typeface="Calibri" pitchFamily="34" charset="-120"/>
               </a:rPr>
-              <a:t>Source: EPA Automotive Trends technology-share series, 1975–2024; logistic fits with bootstrap confidence intervals; dashed = extrapolation.</a:t>
+              <a:t>Source: EPA Automotive Trends technology-share series, 1975–2024; logistic fits with bootstrap confidence intervals; ceiling estimated for completed curves, assumed for hybrid and BEV; dashed = extrapolation.</a:t>
             </a:r>
             <a:endParaRPr lang="en-US" sz="1000" dirty="0"/>
           </a:p>

</xml_diff>

<commit_message>
Fit slide 7 title on one line; untrack a stray local deck copy
MPG Prediction Deck_9-13.pptx was a manual working copy swept into the
previous commit; it is removed from tracking and left on disk.

Co-Authored-By: Claude Fable 5.1 <noreply@anthropic.com>
</commit_message>
<xml_diff>
--- a/MPG Prediction Deck.pptx
+++ b/MPG Prediction Deck.pptx
@@ -24319,7 +24319,7 @@
               <a:buNone/>
             </a:pPr>
             <a:r>
-              <a:rPr lang="en-US" sz="2800" b="1" dirty="0">
+              <a:rPr lang="en-US" sz="2300" b="1" dirty="0">
                 <a:solidFill>
                   <a:srgbClr val="0B0B0B"/>
                 </a:solidFill>
@@ -24329,7 +24329,7 @@
               </a:rPr>
               <a:t>Efficiency technology arrives on S-curves; hybrid and electric are still on the ramp</a:t>
             </a:r>
-            <a:endParaRPr lang="en-US" sz="2800" dirty="0"/>
+            <a:endParaRPr lang="en-US" sz="2300" dirty="0"/>
           </a:p>
         </p:txBody>
       </p:sp>

</xml_diff>